<commit_message>
1d cnn code 구현 및 feature selection 수정(5-fold)
</commit_message>
<xml_diff>
--- a/연구코드/results/0424_vs_0430_comparison.pptx
+++ b/연구코드/results/0424_vs_0430_comparison.pptx
@@ -4423,7 +4423,7 @@
                             <a:srgbClr val="1A1A2E"/>
                           </a:solidFill>
                         </a:rPr>
-                        <a:t>0.6620</a:t>
+                        <a:t>0.4865</a:t>
                       </a:r>
                     </a:p>
                   </a:txBody>
@@ -4445,7 +4445,7 @@
                             <a:srgbClr val="1A1A2E"/>
                           </a:solidFill>
                         </a:rPr>
-                        <a:t>17.12</a:t>
+                        <a:t>6.20</a:t>
                       </a:r>
                     </a:p>
                   </a:txBody>
@@ -4467,7 +4467,7 @@
                             <a:srgbClr val="1A1A2E"/>
                           </a:solidFill>
                         </a:rPr>
-                        <a:t>0.7427</a:t>
+                        <a:t>0.7707</a:t>
                       </a:r>
                     </a:p>
                   </a:txBody>
@@ -4513,7 +4513,7 @@
                             <a:srgbClr val="1A1A2E"/>
                           </a:solidFill>
                         </a:rPr>
-                        <a:t>0.6780</a:t>
+                        <a:t>0.4997</a:t>
                       </a:r>
                     </a:p>
                   </a:txBody>
@@ -4535,7 +4535,7 @@
                             <a:srgbClr val="1A1A2E"/>
                           </a:solidFill>
                         </a:rPr>
-                        <a:t>16.71</a:t>
+                        <a:t>6.13</a:t>
                       </a:r>
                     </a:p>
                   </a:txBody>
@@ -4557,7 +4557,7 @@
                             <a:srgbClr val="1A1A2E"/>
                           </a:solidFill>
                         </a:rPr>
-                        <a:t>0.7510</a:t>
+                        <a:t>0.7715</a:t>
                       </a:r>
                     </a:p>
                   </a:txBody>
@@ -4603,7 +4603,7 @@
                             <a:srgbClr val="1A1A2E"/>
                           </a:solidFill>
                         </a:rPr>
-                        <a:t>0.6694</a:t>
+                        <a:t>0.4960</a:t>
                       </a:r>
                     </a:p>
                   </a:txBody>
@@ -4625,7 +4625,7 @@
                             <a:srgbClr val="1A1A2E"/>
                           </a:solidFill>
                         </a:rPr>
-                        <a:t>16.93</a:t>
+                        <a:t>6.15</a:t>
                       </a:r>
                     </a:p>
                   </a:txBody>
@@ -4647,7 +4647,7 @@
                             <a:srgbClr val="1A1A2E"/>
                           </a:solidFill>
                         </a:rPr>
-                        <a:t>0.7442</a:t>
+                        <a:t>0.7710</a:t>
                       </a:r>
                     </a:p>
                   </a:txBody>
@@ -4693,7 +4693,7 @@
                             <a:srgbClr val="1A1A2E"/>
                           </a:solidFill>
                         </a:rPr>
-                        <a:t>0.6682</a:t>
+                        <a:t>0.4831</a:t>
                       </a:r>
                     </a:p>
                   </a:txBody>
@@ -4715,7 +4715,7 @@
                             <a:srgbClr val="1A1A2E"/>
                           </a:solidFill>
                         </a:rPr>
-                        <a:t>16.96</a:t>
+                        <a:t>6.23</a:t>
                       </a:r>
                     </a:p>
                   </a:txBody>
@@ -4737,7 +4737,7 @@
                             <a:srgbClr val="1A1A2E"/>
                           </a:solidFill>
                         </a:rPr>
-                        <a:t>0.7400</a:t>
+                        <a:t>0.7589</a:t>
                       </a:r>
                     </a:p>
                   </a:txBody>
@@ -4783,7 +4783,7 @@
                             <a:srgbClr val="1A1A2E"/>
                           </a:solidFill>
                         </a:rPr>
-                        <a:t>0.6620</a:t>
+                        <a:t>0.4830</a:t>
                       </a:r>
                     </a:p>
                   </a:txBody>
@@ -4805,7 +4805,7 @@
                             <a:srgbClr val="1A1A2E"/>
                           </a:solidFill>
                         </a:rPr>
-                        <a:t>17.11</a:t>
+                        <a:t>6.23</a:t>
                       </a:r>
                     </a:p>
                   </a:txBody>
@@ -4827,7 +4827,7 @@
                             <a:srgbClr val="1A1A2E"/>
                           </a:solidFill>
                         </a:rPr>
-                        <a:t>0.7311</a:t>
+                        <a:t>0.7564</a:t>
                       </a:r>
                     </a:p>
                   </a:txBody>
@@ -4948,7 +4948,7 @@
                   <a:srgbClr val="2E75B6"/>
                 </a:solidFill>
               </a:rPr>
-              <a:t>Lin R² +0.0160  |  AUC +0.0083</a:t>
+              <a:t>Lin R² +0.0132  |  AUC +0.0008</a:t>
             </a:r>
           </a:p>
         </p:txBody>
@@ -5016,7 +5016,7 @@
                   <a:srgbClr val="008B45"/>
                 </a:solidFill>
               </a:rPr>
-              <a:t>Lin R² +0.0074  |  AUC +0.0015</a:t>
+              <a:t>Lin R² +0.0095  |  AUC +0.0003</a:t>
             </a:r>
           </a:p>
         </p:txBody>
@@ -10889,7 +10889,7 @@
                 <a:gridCol w="1965960"/>
                 <a:gridCol w="1965960"/>
               </a:tblGrid>
-              <a:tr h="333102">
+              <a:tr h="582930">
                 <a:tc>
                   <a:txBody>
                     <a:bodyPr/>
@@ -11023,7 +11023,7 @@
                   </a:tcPr>
                 </a:tc>
               </a:tr>
-              <a:tr h="333102">
+              <a:tr h="582930">
                 <a:tc>
                   <a:txBody>
                     <a:bodyPr/>
@@ -11080,7 +11080,7 @@
                             <a:srgbClr val="1A1A2E"/>
                           </a:solidFill>
                         </a:rPr>
-                        <a:t>+0.1190</a:t>
+                        <a:t>+0.2035</a:t>
                       </a:r>
                     </a:p>
                   </a:txBody>
@@ -11102,7 +11102,7 @@
                             <a:srgbClr val="1A1A2E"/>
                           </a:solidFill>
                         </a:rPr>
-                        <a:t>-2.7900</a:t>
+                        <a:t>-1.1400</a:t>
                       </a:r>
                     </a:p>
                   </a:txBody>
@@ -11124,7 +11124,7 @@
                             <a:srgbClr val="1A1A2E"/>
                           </a:solidFill>
                         </a:rPr>
-                        <a:t>+0.1435</a:t>
+                        <a:t>+0.3052</a:t>
                       </a:r>
                     </a:p>
                   </a:txBody>
@@ -11146,7 +11146,7 @@
                             <a:srgbClr val="1A1A2E"/>
                           </a:solidFill>
                         </a:rPr>
-                        <a:t>-0.0410</a:t>
+                        <a:t>-0.0849</a:t>
                       </a:r>
                     </a:p>
                   </a:txBody>
@@ -11157,7 +11157,7 @@
                   </a:tcPr>
                 </a:tc>
               </a:tr>
-              <a:tr h="333102">
+              <a:tr h="582930">
                 <a:tc>
                   <a:txBody>
                     <a:bodyPr/>
@@ -11171,408 +11171,6 @@
                           </a:solidFill>
                         </a:rPr>
                         <a:t>강남</a:t>
-                      </a:r>
-                    </a:p>
-                  </a:txBody>
-                  <a:tcPr>
-                    <a:solidFill>
-                      <a:srgbClr val="EBFFEB"/>
-                    </a:solidFill>
-                  </a:tcPr>
-                </a:tc>
-                <a:tc>
-                  <a:txBody>
-                    <a:bodyPr/>
-                    <a:lstStyle/>
-                    <a:p>
-                      <a:pPr algn="ctr"/>
-                      <a:r>
-                        <a:rPr sz="1100" b="0">
-                          <a:solidFill>
-                            <a:srgbClr val="1A1A2E"/>
-                          </a:solidFill>
-                        </a:rPr>
-                        <a:t>C2</a:t>
-                      </a:r>
-                    </a:p>
-                  </a:txBody>
-                  <a:tcPr>
-                    <a:solidFill>
-                      <a:srgbClr val="EBFFEB"/>
-                    </a:solidFill>
-                  </a:tcPr>
-                </a:tc>
-                <a:tc>
-                  <a:txBody>
-                    <a:bodyPr/>
-                    <a:lstStyle/>
-                    <a:p>
-                      <a:pPr algn="ctr"/>
-                      <a:r>
-                        <a:rPr sz="1100" b="0">
-                          <a:solidFill>
-                            <a:srgbClr val="1A1A2E"/>
-                          </a:solidFill>
-                        </a:rPr>
-                        <a:t>+0.0480</a:t>
-                      </a:r>
-                    </a:p>
-                  </a:txBody>
-                  <a:tcPr>
-                    <a:solidFill>
-                      <a:srgbClr val="EBFFEB"/>
-                    </a:solidFill>
-                  </a:tcPr>
-                </a:tc>
-                <a:tc>
-                  <a:txBody>
-                    <a:bodyPr/>
-                    <a:lstStyle/>
-                    <a:p>
-                      <a:pPr algn="ctr"/>
-                      <a:r>
-                        <a:rPr sz="1100" b="0">
-                          <a:solidFill>
-                            <a:srgbClr val="1A1A2E"/>
-                          </a:solidFill>
-                        </a:rPr>
-                        <a:t>-1.2000</a:t>
-                      </a:r>
-                    </a:p>
-                  </a:txBody>
-                  <a:tcPr>
-                    <a:solidFill>
-                      <a:srgbClr val="EBFFEB"/>
-                    </a:solidFill>
-                  </a:tcPr>
-                </a:tc>
-                <a:tc>
-                  <a:txBody>
-                    <a:bodyPr/>
-                    <a:lstStyle/>
-                    <a:p>
-                      <a:pPr algn="ctr"/>
-                      <a:r>
-                        <a:rPr sz="1100" b="0">
-                          <a:solidFill>
-                            <a:srgbClr val="1A1A2E"/>
-                          </a:solidFill>
-                        </a:rPr>
-                        <a:t>+0.0510</a:t>
-                      </a:r>
-                    </a:p>
-                  </a:txBody>
-                  <a:tcPr>
-                    <a:solidFill>
-                      <a:srgbClr val="EBFFEB"/>
-                    </a:solidFill>
-                  </a:tcPr>
-                </a:tc>
-                <a:tc>
-                  <a:txBody>
-                    <a:bodyPr/>
-                    <a:lstStyle/>
-                    <a:p>
-                      <a:pPr algn="ctr"/>
-                      <a:r>
-                        <a:rPr sz="1100" b="0">
-                          <a:solidFill>
-                            <a:srgbClr val="1A1A2E"/>
-                          </a:solidFill>
-                        </a:rPr>
-                        <a:t>+0.0806</a:t>
-                      </a:r>
-                    </a:p>
-                  </a:txBody>
-                  <a:tcPr>
-                    <a:solidFill>
-                      <a:srgbClr val="EBFFEB"/>
-                    </a:solidFill>
-                  </a:tcPr>
-                </a:tc>
-              </a:tr>
-              <a:tr h="333102">
-                <a:tc>
-                  <a:txBody>
-                    <a:bodyPr/>
-                    <a:lstStyle/>
-                    <a:p>
-                      <a:pPr algn="l"/>
-                      <a:r>
-                        <a:rPr sz="1100" b="0">
-                          <a:solidFill>
-                            <a:srgbClr val="1A1A2E"/>
-                          </a:solidFill>
-                        </a:rPr>
-                        <a:t>강남</a:t>
-                      </a:r>
-                    </a:p>
-                  </a:txBody>
-                  <a:tcPr>
-                    <a:solidFill>
-                      <a:srgbClr val="EBFFEB"/>
-                    </a:solidFill>
-                  </a:tcPr>
-                </a:tc>
-                <a:tc>
-                  <a:txBody>
-                    <a:bodyPr/>
-                    <a:lstStyle/>
-                    <a:p>
-                      <a:pPr algn="ctr"/>
-                      <a:r>
-                        <a:rPr sz="1100" b="0">
-                          <a:solidFill>
-                            <a:srgbClr val="1A1A2E"/>
-                          </a:solidFill>
-                        </a:rPr>
-                        <a:t>C4</a:t>
-                      </a:r>
-                    </a:p>
-                  </a:txBody>
-                  <a:tcPr>
-                    <a:solidFill>
-                      <a:srgbClr val="EBFFEB"/>
-                    </a:solidFill>
-                  </a:tcPr>
-                </a:tc>
-                <a:tc>
-                  <a:txBody>
-                    <a:bodyPr/>
-                    <a:lstStyle/>
-                    <a:p>
-                      <a:pPr algn="ctr"/>
-                      <a:r>
-                        <a:rPr sz="1100" b="0">
-                          <a:solidFill>
-                            <a:srgbClr val="1A1A2E"/>
-                          </a:solidFill>
-                        </a:rPr>
-                        <a:t>+0.0472</a:t>
-                      </a:r>
-                    </a:p>
-                  </a:txBody>
-                  <a:tcPr>
-                    <a:solidFill>
-                      <a:srgbClr val="EBFFEB"/>
-                    </a:solidFill>
-                  </a:tcPr>
-                </a:tc>
-                <a:tc>
-                  <a:txBody>
-                    <a:bodyPr/>
-                    <a:lstStyle/>
-                    <a:p>
-                      <a:pPr algn="ctr"/>
-                      <a:r>
-                        <a:rPr sz="1100" b="0">
-                          <a:solidFill>
-                            <a:srgbClr val="1A1A2E"/>
-                          </a:solidFill>
-                        </a:rPr>
-                        <a:t>-1.1700</a:t>
-                      </a:r>
-                    </a:p>
-                  </a:txBody>
-                  <a:tcPr>
-                    <a:solidFill>
-                      <a:srgbClr val="EBFFEB"/>
-                    </a:solidFill>
-                  </a:tcPr>
-                </a:tc>
-                <a:tc>
-                  <a:txBody>
-                    <a:bodyPr/>
-                    <a:lstStyle/>
-                    <a:p>
-                      <a:pPr algn="ctr"/>
-                      <a:r>
-                        <a:rPr sz="1100" b="0">
-                          <a:solidFill>
-                            <a:srgbClr val="1A1A2E"/>
-                          </a:solidFill>
-                        </a:rPr>
-                        <a:t>+0.0296</a:t>
-                      </a:r>
-                    </a:p>
-                  </a:txBody>
-                  <a:tcPr>
-                    <a:solidFill>
-                      <a:srgbClr val="EBFFEB"/>
-                    </a:solidFill>
-                  </a:tcPr>
-                </a:tc>
-                <a:tc>
-                  <a:txBody>
-                    <a:bodyPr/>
-                    <a:lstStyle/>
-                    <a:p>
-                      <a:pPr algn="ctr"/>
-                      <a:r>
-                        <a:rPr sz="1100" b="0">
-                          <a:solidFill>
-                            <a:srgbClr val="1A1A2E"/>
-                          </a:solidFill>
-                        </a:rPr>
-                        <a:t>+0.0330</a:t>
-                      </a:r>
-                    </a:p>
-                  </a:txBody>
-                  <a:tcPr>
-                    <a:solidFill>
-                      <a:srgbClr val="EBFFEB"/>
-                    </a:solidFill>
-                  </a:tcPr>
-                </a:tc>
-              </a:tr>
-              <a:tr h="333102">
-                <a:tc>
-                  <a:txBody>
-                    <a:bodyPr/>
-                    <a:lstStyle/>
-                    <a:p>
-                      <a:pPr algn="l"/>
-                      <a:r>
-                        <a:rPr sz="1100" b="0">
-                          <a:solidFill>
-                            <a:srgbClr val="1A1A2E"/>
-                          </a:solidFill>
-                        </a:rPr>
-                        <a:t>신촌</a:t>
-                      </a:r>
-                    </a:p>
-                  </a:txBody>
-                  <a:tcPr>
-                    <a:solidFill>
-                      <a:srgbClr val="D6F5D6"/>
-                    </a:solidFill>
-                  </a:tcPr>
-                </a:tc>
-                <a:tc>
-                  <a:txBody>
-                    <a:bodyPr/>
-                    <a:lstStyle/>
-                    <a:p>
-                      <a:pPr algn="ctr"/>
-                      <a:r>
-                        <a:rPr sz="1100" b="0">
-                          <a:solidFill>
-                            <a:srgbClr val="1A1A2E"/>
-                          </a:solidFill>
-                        </a:rPr>
-                        <a:t>C1</a:t>
-                      </a:r>
-                    </a:p>
-                  </a:txBody>
-                  <a:tcPr>
-                    <a:solidFill>
-                      <a:srgbClr val="D6F5D6"/>
-                    </a:solidFill>
-                  </a:tcPr>
-                </a:tc>
-                <a:tc>
-                  <a:txBody>
-                    <a:bodyPr/>
-                    <a:lstStyle/>
-                    <a:p>
-                      <a:pPr algn="ctr"/>
-                      <a:r>
-                        <a:rPr sz="1100" b="0">
-                          <a:solidFill>
-                            <a:srgbClr val="1A1A2E"/>
-                          </a:solidFill>
-                        </a:rPr>
-                        <a:t>+0.1182</a:t>
-                      </a:r>
-                    </a:p>
-                  </a:txBody>
-                  <a:tcPr>
-                    <a:solidFill>
-                      <a:srgbClr val="D6F5D6"/>
-                    </a:solidFill>
-                  </a:tcPr>
-                </a:tc>
-                <a:tc>
-                  <a:txBody>
-                    <a:bodyPr/>
-                    <a:lstStyle/>
-                    <a:p>
-                      <a:pPr algn="ctr"/>
-                      <a:r>
-                        <a:rPr sz="1100" b="0">
-                          <a:solidFill>
-                            <a:srgbClr val="1A1A2E"/>
-                          </a:solidFill>
-                        </a:rPr>
-                        <a:t>-2.8200</a:t>
-                      </a:r>
-                    </a:p>
-                  </a:txBody>
-                  <a:tcPr>
-                    <a:solidFill>
-                      <a:srgbClr val="D6F5D6"/>
-                    </a:solidFill>
-                  </a:tcPr>
-                </a:tc>
-                <a:tc>
-                  <a:txBody>
-                    <a:bodyPr/>
-                    <a:lstStyle/>
-                    <a:p>
-                      <a:pPr algn="ctr"/>
-                      <a:r>
-                        <a:rPr sz="1100" b="0">
-                          <a:solidFill>
-                            <a:srgbClr val="1A1A2E"/>
-                          </a:solidFill>
-                        </a:rPr>
-                        <a:t>+0.1437</a:t>
-                      </a:r>
-                    </a:p>
-                  </a:txBody>
-                  <a:tcPr>
-                    <a:solidFill>
-                      <a:srgbClr val="D6F5D6"/>
-                    </a:solidFill>
-                  </a:tcPr>
-                </a:tc>
-                <a:tc>
-                  <a:txBody>
-                    <a:bodyPr/>
-                    <a:lstStyle/>
-                    <a:p>
-                      <a:pPr algn="ctr"/>
-                      <a:r>
-                        <a:rPr sz="1100" b="0">
-                          <a:solidFill>
-                            <a:srgbClr val="1A1A2E"/>
-                          </a:solidFill>
-                        </a:rPr>
-                        <a:t>-0.0047</a:t>
-                      </a:r>
-                    </a:p>
-                  </a:txBody>
-                  <a:tcPr>
-                    <a:solidFill>
-                      <a:srgbClr val="D6F5D6"/>
-                    </a:solidFill>
-                  </a:tcPr>
-                </a:tc>
-              </a:tr>
-              <a:tr h="333102">
-                <a:tc>
-                  <a:txBody>
-                    <a:bodyPr/>
-                    <a:lstStyle/>
-                    <a:p>
-                      <a:pPr algn="l"/>
-                      <a:r>
-                        <a:rPr sz="1100" b="0">
-                          <a:solidFill>
-                            <a:srgbClr val="1A1A2E"/>
-                          </a:solidFill>
-                        </a:rPr>
-                        <a:t>신촌</a:t>
                       </a:r>
                     </a:p>
                   </a:txBody>
@@ -11616,7 +11214,7 @@
                             <a:srgbClr val="1A1A2E"/>
                           </a:solidFill>
                         </a:rPr>
-                        <a:t>+0.0971</a:t>
+                        <a:t>+0.0908</a:t>
                       </a:r>
                     </a:p>
                   </a:txBody>
@@ -11638,7 +11236,7 @@
                             <a:srgbClr val="1A1A2E"/>
                           </a:solidFill>
                         </a:rPr>
-                        <a:t>-2.3600</a:t>
+                        <a:t>-0.5300</a:t>
                       </a:r>
                     </a:p>
                   </a:txBody>
@@ -11660,7 +11258,7 @@
                             <a:srgbClr val="1A1A2E"/>
                           </a:solidFill>
                         </a:rPr>
-                        <a:t>+0.1061</a:t>
+                        <a:t>+0.0902</a:t>
                       </a:r>
                     </a:p>
                   </a:txBody>
@@ -11682,7 +11280,7 @@
                             <a:srgbClr val="1A1A2E"/>
                           </a:solidFill>
                         </a:rPr>
-                        <a:t>+0.0150</a:t>
+                        <a:t>+0.0967</a:t>
                       </a:r>
                     </a:p>
                   </a:txBody>
@@ -11693,7 +11291,7 @@
                   </a:tcPr>
                 </a:tc>
               </a:tr>
-              <a:tr h="333108">
+              <a:tr h="582930">
                 <a:tc>
                   <a:txBody>
                     <a:bodyPr/>
@@ -11706,7 +11304,7 @@
                             <a:srgbClr val="1A1A2E"/>
                           </a:solidFill>
                         </a:rPr>
-                        <a:t>신촌</a:t>
+                        <a:t>강남</a:t>
                       </a:r>
                     </a:p>
                   </a:txBody>
@@ -11750,7 +11348,7 @@
                             <a:srgbClr val="1A1A2E"/>
                           </a:solidFill>
                         </a:rPr>
-                        <a:t>+0.0990</a:t>
+                        <a:t>+0.0940</a:t>
                       </a:r>
                     </a:p>
                   </a:txBody>
@@ -11772,7 +11370,7 @@
                             <a:srgbClr val="1A1A2E"/>
                           </a:solidFill>
                         </a:rPr>
-                        <a:t>-2.3600</a:t>
+                        <a:t>-0.5400</a:t>
                       </a:r>
                     </a:p>
                   </a:txBody>
@@ -11794,7 +11392,7 @@
                             <a:srgbClr val="1A1A2E"/>
                           </a:solidFill>
                         </a:rPr>
-                        <a:t>+0.0745</a:t>
+                        <a:t>+0.0750</a:t>
                       </a:r>
                     </a:p>
                   </a:txBody>
@@ -11816,7 +11414,7 @@
                             <a:srgbClr val="1A1A2E"/>
                           </a:solidFill>
                         </a:rPr>
-                        <a:t>+0.0403</a:t>
+                        <a:t>+0.0461</a:t>
                       </a:r>
                     </a:p>
                   </a:txBody>

</xml_diff>